<commit_message>
Add Team REIGN contributions beyond the paper; update deck
Co-Authored-By: Claude Opus 5.5 <noreply@anthropic.com>
</commit_message>
<xml_diff>
--- a/docs/VILLE_Team_REIGN_Ideation.pptx
+++ b/docs/VILLE_Team_REIGN_Ideation.pptx
@@ -15,6 +15,7 @@
     <p:sldId id="263" r:id="rId14"/>
     <p:sldId id="264" r:id="rId15"/>
     <p:sldId id="265" r:id="rId16"/>
+    <p:sldId id="266" r:id="rId17"/>
   </p:sldIdLst>
   <p:sldSz cx="12191695" cy="6858000" type="screen4x3"/>
   <p:notesSz cx="6858000" cy="9144000"/>
@@ -3434,7 +3435,7 @@
                 </a:solidFill>
                 <a:latin typeface="Arial"/>
               </a:rPr>
-              <a:t>09  ·  FUTURE SCOPE &amp; IMPACT</a:t>
+              <a:t>09  ·  FEASIBILITY &amp; KNOWN LIMITS</a:t>
             </a:r>
           </a:p>
         </p:txBody>
@@ -3473,6 +3474,601 @@
                 </a:solidFill>
                 <a:latin typeface="Georgia"/>
               </a:rPr>
+              <a:t>What the paper says it cannot yet do</a:t>
+            </a:r>
+          </a:p>
+        </p:txBody>
+      </p:sp>
+      <p:cxnSp>
+        <p:nvCxnSpPr>
+          <p:cNvPr id="4" name="Connector 3"/>
+          <p:cNvCxnSpPr/>
+          <p:nvPr/>
+        </p:nvCxnSpPr>
+        <p:spPr>
+          <a:xfrm>
+            <a:off x="777240" y="1920240"/>
+            <a:ext cx="5088636" cy="0"/>
+          </a:xfrm>
+          <a:prstGeom prst="line">
+            <a:avLst/>
+          </a:prstGeom>
+          <a:ln w="19050">
+            <a:solidFill>
+              <a:srgbClr val="1E1E1E"/>
+            </a:solidFill>
+          </a:ln>
+        </p:spPr>
+        <p:style>
+          <a:lnRef idx="2">
+            <a:schemeClr val="accent1"/>
+          </a:lnRef>
+          <a:fillRef idx="0">
+            <a:schemeClr val="accent1"/>
+          </a:fillRef>
+          <a:effectRef idx="1">
+            <a:schemeClr val="accent1"/>
+          </a:effectRef>
+          <a:fontRef idx="minor">
+            <a:schemeClr val="tx1"/>
+          </a:fontRef>
+        </p:style>
+      </p:cxnSp>
+      <p:sp>
+        <p:nvSpPr>
+          <p:cNvPr id="5" name="TextBox 4"/>
+          <p:cNvSpPr txBox="1"/>
+          <p:nvPr/>
+        </p:nvSpPr>
+        <p:spPr>
+          <a:xfrm>
+            <a:off x="777240" y="2057400"/>
+            <a:ext cx="5088636" cy="411480"/>
+          </a:xfrm>
+          <a:prstGeom prst="rect">
+            <a:avLst/>
+          </a:prstGeom>
+          <a:noFill/>
+        </p:spPr>
+        <p:txBody>
+          <a:bodyPr wrap="square" anchor="t" lIns="0" rIns="0" tIns="0" bIns="0">
+            <a:spAutoFit/>
+          </a:bodyPr>
+          <a:lstStyle/>
+          <a:p>
+            <a:pPr algn="l">
+              <a:lnSpc>
+                <a:spcPct val="115000"/>
+              </a:lnSpc>
+            </a:pPr>
+            <a:r>
+              <a:rPr sz="1900" b="1" i="0">
+                <a:solidFill>
+                  <a:srgbClr val="1E1E1E"/>
+                </a:solidFill>
+                <a:latin typeface="Arial"/>
+              </a:rPr>
+              <a:t>Slow, seed-aware attackers</a:t>
+            </a:r>
+          </a:p>
+        </p:txBody>
+      </p:sp>
+      <p:sp>
+        <p:nvSpPr>
+          <p:cNvPr id="6" name="TextBox 5"/>
+          <p:cNvSpPr txBox="1"/>
+          <p:nvPr/>
+        </p:nvSpPr>
+        <p:spPr>
+          <a:xfrm>
+            <a:off x="777240" y="2468880"/>
+            <a:ext cx="5088636" cy="1051560"/>
+          </a:xfrm>
+          <a:prstGeom prst="rect">
+            <a:avLst/>
+          </a:prstGeom>
+          <a:noFill/>
+        </p:spPr>
+        <p:txBody>
+          <a:bodyPr wrap="square" anchor="t" lIns="0" rIns="0" tIns="0" bIns="0">
+            <a:spAutoFit/>
+          </a:bodyPr>
+          <a:lstStyle/>
+          <a:p>
+            <a:pPr algn="l">
+              <a:lnSpc>
+                <a:spcPct val="130000"/>
+              </a:lnSpc>
+            </a:pPr>
+            <a:r>
+              <a:rPr sz="1500" b="0" i="0">
+                <a:solidFill>
+                  <a:srgbClr val="404040"/>
+                </a:solidFill>
+                <a:latin typeface="Arial"/>
+              </a:rPr>
+              <a:t>Attacks sending a few hundredths of a bit per token can go undetected within 250 responses.</a:t>
+            </a:r>
+          </a:p>
+        </p:txBody>
+      </p:sp>
+      <p:cxnSp>
+        <p:nvCxnSpPr>
+          <p:cNvPr id="7" name="Connector 6"/>
+          <p:cNvCxnSpPr/>
+          <p:nvPr/>
+        </p:nvCxnSpPr>
+        <p:spPr>
+          <a:xfrm>
+            <a:off x="6323076" y="1920240"/>
+            <a:ext cx="5088636" cy="0"/>
+          </a:xfrm>
+          <a:prstGeom prst="line">
+            <a:avLst/>
+          </a:prstGeom>
+          <a:ln w="19050">
+            <a:solidFill>
+              <a:srgbClr val="1E1E1E"/>
+            </a:solidFill>
+          </a:ln>
+        </p:spPr>
+        <p:style>
+          <a:lnRef idx="2">
+            <a:schemeClr val="accent1"/>
+          </a:lnRef>
+          <a:fillRef idx="0">
+            <a:schemeClr val="accent1"/>
+          </a:fillRef>
+          <a:effectRef idx="1">
+            <a:schemeClr val="accent1"/>
+          </a:effectRef>
+          <a:fontRef idx="minor">
+            <a:schemeClr val="tx1"/>
+          </a:fontRef>
+        </p:style>
+      </p:cxnSp>
+      <p:sp>
+        <p:nvSpPr>
+          <p:cNvPr id="8" name="TextBox 7"/>
+          <p:cNvSpPr txBox="1"/>
+          <p:nvPr/>
+        </p:nvSpPr>
+        <p:spPr>
+          <a:xfrm>
+            <a:off x="6323076" y="2057400"/>
+            <a:ext cx="5088636" cy="411480"/>
+          </a:xfrm>
+          <a:prstGeom prst="rect">
+            <a:avLst/>
+          </a:prstGeom>
+          <a:noFill/>
+        </p:spPr>
+        <p:txBody>
+          <a:bodyPr wrap="square" anchor="t" lIns="0" rIns="0" tIns="0" bIns="0">
+            <a:spAutoFit/>
+          </a:bodyPr>
+          <a:lstStyle/>
+          <a:p>
+            <a:pPr algn="l">
+              <a:lnSpc>
+                <a:spcPct val="115000"/>
+              </a:lnSpc>
+            </a:pPr>
+            <a:r>
+              <a:rPr sz="1900" b="1" i="0">
+                <a:solidFill>
+                  <a:srgbClr val="1E1E1E"/>
+                </a:solidFill>
+                <a:latin typeface="Arial"/>
+              </a:rPr>
+              <a:t>Noisier model stacks</a:t>
+            </a:r>
+          </a:p>
+        </p:txBody>
+      </p:sp>
+      <p:sp>
+        <p:nvSpPr>
+          <p:cNvPr id="9" name="TextBox 8"/>
+          <p:cNvSpPr txBox="1"/>
+          <p:nvPr/>
+        </p:nvSpPr>
+        <p:spPr>
+          <a:xfrm>
+            <a:off x="6323076" y="2468880"/>
+            <a:ext cx="5088636" cy="1051560"/>
+          </a:xfrm>
+          <a:prstGeom prst="rect">
+            <a:avLst/>
+          </a:prstGeom>
+          <a:noFill/>
+        </p:spPr>
+        <p:txBody>
+          <a:bodyPr wrap="square" anchor="t" lIns="0" rIns="0" tIns="0" bIns="0">
+            <a:spAutoFit/>
+          </a:bodyPr>
+          <a:lstStyle/>
+          <a:p>
+            <a:pPr algn="l">
+              <a:lnSpc>
+                <a:spcPct val="130000"/>
+              </a:lnSpc>
+            </a:pPr>
+            <a:r>
+              <a:rPr sz="1500" b="0" i="0">
+                <a:solidFill>
+                  <a:srgbClr val="404040"/>
+                </a:solidFill>
+                <a:latin typeface="Arial"/>
+              </a:rPr>
+              <a:t>Both mixture-of-experts models showed 3–4× more benign mismatches, giving attackers more cover.</a:t>
+            </a:r>
+          </a:p>
+        </p:txBody>
+      </p:sp>
+      <p:cxnSp>
+        <p:nvCxnSpPr>
+          <p:cNvPr id="10" name="Connector 9"/>
+          <p:cNvCxnSpPr/>
+          <p:nvPr/>
+        </p:nvCxnSpPr>
+        <p:spPr>
+          <a:xfrm>
+            <a:off x="777240" y="3794760"/>
+            <a:ext cx="5088636" cy="0"/>
+          </a:xfrm>
+          <a:prstGeom prst="line">
+            <a:avLst/>
+          </a:prstGeom>
+          <a:ln w="19050">
+            <a:solidFill>
+              <a:srgbClr val="1E1E1E"/>
+            </a:solidFill>
+          </a:ln>
+        </p:spPr>
+        <p:style>
+          <a:lnRef idx="2">
+            <a:schemeClr val="accent1"/>
+          </a:lnRef>
+          <a:fillRef idx="0">
+            <a:schemeClr val="accent1"/>
+          </a:fillRef>
+          <a:effectRef idx="1">
+            <a:schemeClr val="accent1"/>
+          </a:effectRef>
+          <a:fontRef idx="minor">
+            <a:schemeClr val="tx1"/>
+          </a:fontRef>
+        </p:style>
+      </p:cxnSp>
+      <p:sp>
+        <p:nvSpPr>
+          <p:cNvPr id="11" name="TextBox 10"/>
+          <p:cNvSpPr txBox="1"/>
+          <p:nvPr/>
+        </p:nvSpPr>
+        <p:spPr>
+          <a:xfrm>
+            <a:off x="777240" y="3931920"/>
+            <a:ext cx="5088636" cy="411480"/>
+          </a:xfrm>
+          <a:prstGeom prst="rect">
+            <a:avLst/>
+          </a:prstGeom>
+          <a:noFill/>
+        </p:spPr>
+        <p:txBody>
+          <a:bodyPr wrap="square" anchor="t" lIns="0" rIns="0" tIns="0" bIns="0">
+            <a:spAutoFit/>
+          </a:bodyPr>
+          <a:lstStyle/>
+          <a:p>
+            <a:pPr algn="l">
+              <a:lnSpc>
+                <a:spcPct val="115000"/>
+              </a:lnSpc>
+            </a:pPr>
+            <a:r>
+              <a:rPr sz="1900" b="1" i="0">
+                <a:solidFill>
+                  <a:srgbClr val="1E1E1E"/>
+                </a:solidFill>
+                <a:latin typeface="Arial"/>
+              </a:rPr>
+              <a:t>Calibration must transfer</a:t>
+            </a:r>
+          </a:p>
+        </p:txBody>
+      </p:sp>
+      <p:sp>
+        <p:nvSpPr>
+          <p:cNvPr id="12" name="TextBox 11"/>
+          <p:cNvSpPr txBox="1"/>
+          <p:nvPr/>
+        </p:nvSpPr>
+        <p:spPr>
+          <a:xfrm>
+            <a:off x="777240" y="4343400"/>
+            <a:ext cx="5088636" cy="1051560"/>
+          </a:xfrm>
+          <a:prstGeom prst="rect">
+            <a:avLst/>
+          </a:prstGeom>
+          <a:noFill/>
+        </p:spPr>
+        <p:txBody>
+          <a:bodyPr wrap="square" anchor="t" lIns="0" rIns="0" tIns="0" bIns="0">
+            <a:spAutoFit/>
+          </a:bodyPr>
+          <a:lstStyle/>
+          <a:p>
+            <a:pPr algn="l">
+              <a:lnSpc>
+                <a:spcPct val="130000"/>
+              </a:lnSpc>
+            </a:pPr>
+            <a:r>
+              <a:rPr sz="1500" b="0" i="0">
+                <a:solidFill>
+                  <a:srgbClr val="404040"/>
+                </a:solidFill>
+                <a:latin typeface="Arial"/>
+              </a:rPr>
+              <a:t>The guarantee assumes the same prompts, model, hardware and serving stack as calibration.</a:t>
+            </a:r>
+          </a:p>
+        </p:txBody>
+      </p:sp>
+      <p:cxnSp>
+        <p:nvCxnSpPr>
+          <p:cNvPr id="13" name="Connector 12"/>
+          <p:cNvCxnSpPr/>
+          <p:nvPr/>
+        </p:nvCxnSpPr>
+        <p:spPr>
+          <a:xfrm>
+            <a:off x="6323076" y="3794760"/>
+            <a:ext cx="5088636" cy="0"/>
+          </a:xfrm>
+          <a:prstGeom prst="line">
+            <a:avLst/>
+          </a:prstGeom>
+          <a:ln w="19050">
+            <a:solidFill>
+              <a:srgbClr val="1E1E1E"/>
+            </a:solidFill>
+          </a:ln>
+        </p:spPr>
+        <p:style>
+          <a:lnRef idx="2">
+            <a:schemeClr val="accent1"/>
+          </a:lnRef>
+          <a:fillRef idx="0">
+            <a:schemeClr val="accent1"/>
+          </a:fillRef>
+          <a:effectRef idx="1">
+            <a:schemeClr val="accent1"/>
+          </a:effectRef>
+          <a:fontRef idx="minor">
+            <a:schemeClr val="tx1"/>
+          </a:fontRef>
+        </p:style>
+      </p:cxnSp>
+      <p:sp>
+        <p:nvSpPr>
+          <p:cNvPr id="14" name="TextBox 13"/>
+          <p:cNvSpPr txBox="1"/>
+          <p:nvPr/>
+        </p:nvSpPr>
+        <p:spPr>
+          <a:xfrm>
+            <a:off x="6323076" y="3931920"/>
+            <a:ext cx="5088636" cy="411480"/>
+          </a:xfrm>
+          <a:prstGeom prst="rect">
+            <a:avLst/>
+          </a:prstGeom>
+          <a:noFill/>
+        </p:spPr>
+        <p:txBody>
+          <a:bodyPr wrap="square" anchor="t" lIns="0" rIns="0" tIns="0" bIns="0">
+            <a:spAutoFit/>
+          </a:bodyPr>
+          <a:lstStyle/>
+          <a:p>
+            <a:pPr algn="l">
+              <a:lnSpc>
+                <a:spcPct val="115000"/>
+              </a:lnSpc>
+            </a:pPr>
+            <a:r>
+              <a:rPr sz="1900" b="1" i="0">
+                <a:solidFill>
+                  <a:srgbClr val="1E1E1E"/>
+                </a:solidFill>
+                <a:latin typeface="Arial"/>
+              </a:rPr>
+              <a:t>Small secrets still escape</a:t>
+            </a:r>
+          </a:p>
+        </p:txBody>
+      </p:sp>
+      <p:sp>
+        <p:nvSpPr>
+          <p:cNvPr id="15" name="TextBox 14"/>
+          <p:cNvSpPr txBox="1"/>
+          <p:nvPr/>
+        </p:nvSpPr>
+        <p:spPr>
+          <a:xfrm>
+            <a:off x="6323076" y="4343400"/>
+            <a:ext cx="5088636" cy="1051560"/>
+          </a:xfrm>
+          <a:prstGeom prst="rect">
+            <a:avLst/>
+          </a:prstGeom>
+          <a:noFill/>
+        </p:spPr>
+        <p:txBody>
+          <a:bodyPr wrap="square" anchor="t" lIns="0" rIns="0" tIns="0" bIns="0">
+            <a:spAutoFit/>
+          </a:bodyPr>
+          <a:lstStyle/>
+          <a:p>
+            <a:pPr algn="l">
+              <a:lnSpc>
+                <a:spcPct val="130000"/>
+              </a:lnSpc>
+            </a:pPr>
+            <a:r>
+              <a:rPr sz="1500" b="0" i="0">
+                <a:solidFill>
+                  <a:srgbClr val="404040"/>
+                </a:solidFill>
+                <a:latin typeface="Arial"/>
+              </a:rPr>
+              <a:t>Low rates slow bulk weight theft, but do not stop leaking short secrets such as keys.</a:t>
+            </a:r>
+          </a:p>
+        </p:txBody>
+      </p:sp>
+      <p:sp>
+        <p:nvSpPr>
+          <p:cNvPr id="16" name="TextBox 15"/>
+          <p:cNvSpPr txBox="1"/>
+          <p:nvPr/>
+        </p:nvSpPr>
+        <p:spPr>
+          <a:xfrm>
+            <a:off x="9966960" y="6263640"/>
+            <a:ext cx="1444752" cy="274320"/>
+          </a:xfrm>
+          <a:prstGeom prst="rect">
+            <a:avLst/>
+          </a:prstGeom>
+          <a:noFill/>
+        </p:spPr>
+        <p:txBody>
+          <a:bodyPr wrap="square" anchor="t" lIns="0" rIns="0" tIns="0" bIns="0">
+            <a:spAutoFit/>
+          </a:bodyPr>
+          <a:lstStyle/>
+          <a:p>
+            <a:pPr algn="r">
+              <a:lnSpc>
+                <a:spcPct val="115000"/>
+              </a:lnSpc>
+            </a:pPr>
+            <a:r>
+              <a:rPr sz="1100" b="0" i="0">
+                <a:solidFill>
+                  <a:srgbClr val="6B6B6B"/>
+                </a:solidFill>
+                <a:latin typeface="Arial"/>
+              </a:rPr>
+              <a:t>Team REIGN  ·  10</a:t>
+            </a:r>
+          </a:p>
+        </p:txBody>
+      </p:sp>
+    </p:spTree>
+  </p:cSld>
+  <p:clrMapOvr>
+    <a:masterClrMapping/>
+  </p:clrMapOvr>
+</p:sld>
+</file>
+
+<file path=ppt/slides/slide11.xml><?xml version="1.0" encoding="utf-8"?>
+<p:sld xmlns:a="http://schemas.openxmlformats.org/drawingml/2006/main" xmlns:p="http://schemas.openxmlformats.org/presentationml/2006/main" xmlns:r="http://schemas.openxmlformats.org/officeDocument/2006/relationships">
+  <p:cSld>
+    <p:bg>
+      <p:bgPr>
+        <a:solidFill>
+          <a:srgbClr val="FAF8F3"/>
+        </a:solidFill>
+        <a:effectLst/>
+      </p:bgPr>
+    </p:bg>
+    <p:spTree>
+      <p:nvGrpSpPr>
+        <p:cNvPr id="1" name=""/>
+        <p:cNvGrpSpPr/>
+        <p:nvPr/>
+      </p:nvGrpSpPr>
+      <p:grpSpPr/>
+      <p:sp>
+        <p:nvSpPr>
+          <p:cNvPr id="2" name="TextBox 1"/>
+          <p:cNvSpPr txBox="1"/>
+          <p:nvPr/>
+        </p:nvSpPr>
+        <p:spPr>
+          <a:xfrm>
+            <a:off x="777240" y="548640"/>
+            <a:ext cx="10634472" cy="365760"/>
+          </a:xfrm>
+          <a:prstGeom prst="rect">
+            <a:avLst/>
+          </a:prstGeom>
+          <a:noFill/>
+        </p:spPr>
+        <p:txBody>
+          <a:bodyPr wrap="square" anchor="t" lIns="0" rIns="0" tIns="0" bIns="0">
+            <a:spAutoFit/>
+          </a:bodyPr>
+          <a:lstStyle/>
+          <a:p>
+            <a:pPr algn="l">
+              <a:lnSpc>
+                <a:spcPct val="115000"/>
+              </a:lnSpc>
+            </a:pPr>
+            <a:r>
+              <a:rPr sz="1300" b="1" i="0">
+                <a:solidFill>
+                  <a:srgbClr val="7A1F1F"/>
+                </a:solidFill>
+                <a:latin typeface="Arial"/>
+              </a:rPr>
+              <a:t>10  ·  FUTURE SCOPE &amp; IMPACT</a:t>
+            </a:r>
+          </a:p>
+        </p:txBody>
+      </p:sp>
+      <p:sp>
+        <p:nvSpPr>
+          <p:cNvPr id="3" name="TextBox 2"/>
+          <p:cNvSpPr txBox="1"/>
+          <p:nvPr/>
+        </p:nvSpPr>
+        <p:spPr>
+          <a:xfrm>
+            <a:off x="777240" y="914400"/>
+            <a:ext cx="10634472" cy="1280160"/>
+          </a:xfrm>
+          <a:prstGeom prst="rect">
+            <a:avLst/>
+          </a:prstGeom>
+          <a:noFill/>
+        </p:spPr>
+        <p:txBody>
+          <a:bodyPr wrap="square" anchor="t" lIns="0" rIns="0" tIns="0" bIns="0">
+            <a:spAutoFit/>
+          </a:bodyPr>
+          <a:lstStyle/>
+          <a:p>
+            <a:pPr algn="l">
+              <a:lnSpc>
+                <a:spcPct val="110000"/>
+              </a:lnSpc>
+            </a:pPr>
+            <a:r>
+              <a:rPr sz="3400" b="0" i="0">
+                <a:solidFill>
+                  <a:srgbClr val="1E1E1E"/>
+                </a:solidFill>
+                <a:latin typeface="Georgia"/>
+              </a:rPr>
               <a:t>Our plan</a:t>
             </a:r>
           </a:p>
@@ -3512,7 +4108,7 @@
                 </a:solidFill>
                 <a:latin typeface="Arial"/>
               </a:rPr>
-              <a:t>1.  Reproduce the paper’s results on Llama-3.2-3B with open code.</a:t>
+              <a:t>1.  Reproduce the paper’s results on Llama-3.2-3B with open code (our implementation).</a:t>
             </a:r>
           </a:p>
           <a:p>
@@ -3544,7 +4140,7 @@
                 </a:solidFill>
                 <a:latin typeface="Arial"/>
               </a:rPr>
-              <a:t>3.  Deploy as a sidecar for inference servers, with audit-ready alerts.</a:t>
+              <a:t>3.  Ship our additions: sidecar, drift guard, automatic response and the unified SOC view.</a:t>
             </a:r>
           </a:p>
         </p:txBody>
@@ -6529,7 +7125,641 @@
                 </a:solidFill>
                 <a:latin typeface="Arial"/>
               </a:rPr>
-              <a:t>07  ·  PROPOSED TECHNOLOGY STACK</a:t>
+              <a:t>07  ·  WHAT TEAM REIGN ADDS</a:t>
+            </a:r>
+          </a:p>
+        </p:txBody>
+      </p:sp>
+      <p:sp>
+        <p:nvSpPr>
+          <p:cNvPr id="3" name="TextBox 2"/>
+          <p:cNvSpPr txBox="1"/>
+          <p:nvPr/>
+        </p:nvSpPr>
+        <p:spPr>
+          <a:xfrm>
+            <a:off x="777240" y="914400"/>
+            <a:ext cx="10634472" cy="1280160"/>
+          </a:xfrm>
+          <a:prstGeom prst="rect">
+            <a:avLst/>
+          </a:prstGeom>
+          <a:noFill/>
+        </p:spPr>
+        <p:txBody>
+          <a:bodyPr wrap="square" anchor="t" lIns="0" rIns="0" tIns="0" bIns="0">
+            <a:spAutoFit/>
+          </a:bodyPr>
+          <a:lstStyle/>
+          <a:p>
+            <a:pPr algn="l">
+              <a:lnSpc>
+                <a:spcPct val="110000"/>
+              </a:lnSpc>
+            </a:pPr>
+            <a:r>
+              <a:rPr sz="3000" b="0" i="0">
+                <a:solidFill>
+                  <a:srgbClr val="1E1E1E"/>
+                </a:solidFill>
+                <a:latin typeface="Georgia"/>
+              </a:rPr>
+              <a:t>The paper gives the detector. We turn it into a defence system.</a:t>
+            </a:r>
+          </a:p>
+        </p:txBody>
+      </p:sp>
+      <p:cxnSp>
+        <p:nvCxnSpPr>
+          <p:cNvPr id="4" name="Connector 3"/>
+          <p:cNvCxnSpPr/>
+          <p:nvPr/>
+        </p:nvCxnSpPr>
+        <p:spPr>
+          <a:xfrm>
+            <a:off x="777240" y="2057400"/>
+            <a:ext cx="5088636" cy="0"/>
+          </a:xfrm>
+          <a:prstGeom prst="line">
+            <a:avLst/>
+          </a:prstGeom>
+          <a:ln w="19050">
+            <a:solidFill>
+              <a:srgbClr val="1E1E1E"/>
+            </a:solidFill>
+          </a:ln>
+        </p:spPr>
+        <p:style>
+          <a:lnRef idx="2">
+            <a:schemeClr val="accent1"/>
+          </a:lnRef>
+          <a:fillRef idx="0">
+            <a:schemeClr val="accent1"/>
+          </a:fillRef>
+          <a:effectRef idx="1">
+            <a:schemeClr val="accent1"/>
+          </a:effectRef>
+          <a:fontRef idx="minor">
+            <a:schemeClr val="tx1"/>
+          </a:fontRef>
+        </p:style>
+      </p:cxnSp>
+      <p:sp>
+        <p:nvSpPr>
+          <p:cNvPr id="5" name="TextBox 4"/>
+          <p:cNvSpPr txBox="1"/>
+          <p:nvPr/>
+        </p:nvSpPr>
+        <p:spPr>
+          <a:xfrm>
+            <a:off x="777240" y="2194560"/>
+            <a:ext cx="5088636" cy="411480"/>
+          </a:xfrm>
+          <a:prstGeom prst="rect">
+            <a:avLst/>
+          </a:prstGeom>
+          <a:noFill/>
+        </p:spPr>
+        <p:txBody>
+          <a:bodyPr wrap="square" anchor="t" lIns="0" rIns="0" tIns="0" bIns="0">
+            <a:spAutoFit/>
+          </a:bodyPr>
+          <a:lstStyle/>
+          <a:p>
+            <a:pPr algn="l">
+              <a:lnSpc>
+                <a:spcPct val="115000"/>
+              </a:lnSpc>
+            </a:pPr>
+            <a:r>
+              <a:rPr sz="1900" b="1" i="0">
+                <a:solidFill>
+                  <a:srgbClr val="1E1E1E"/>
+                </a:solidFill>
+                <a:latin typeface="Arial"/>
+              </a:rPr>
+              <a:t>1 · Drop-in sidecar</a:t>
+            </a:r>
+          </a:p>
+        </p:txBody>
+      </p:sp>
+      <p:sp>
+        <p:nvSpPr>
+          <p:cNvPr id="6" name="TextBox 5"/>
+          <p:cNvSpPr txBox="1"/>
+          <p:nvPr/>
+        </p:nvSpPr>
+        <p:spPr>
+          <a:xfrm>
+            <a:off x="777240" y="2606040"/>
+            <a:ext cx="5088636" cy="1051560"/>
+          </a:xfrm>
+          <a:prstGeom prst="rect">
+            <a:avLst/>
+          </a:prstGeom>
+          <a:noFill/>
+        </p:spPr>
+        <p:txBody>
+          <a:bodyPr wrap="square" anchor="t" lIns="0" rIns="0" tIns="0" bIns="0">
+            <a:spAutoFit/>
+          </a:bodyPr>
+          <a:lstStyle/>
+          <a:p>
+            <a:pPr algn="l">
+              <a:lnSpc>
+                <a:spcPct val="130000"/>
+              </a:lnSpc>
+            </a:pPr>
+            <a:r>
+              <a:rPr sz="1400" b="0" i="0">
+                <a:solidFill>
+                  <a:srgbClr val="404040"/>
+                </a:solidFill>
+                <a:latin typeface="Arial"/>
+              </a:rPr>
+              <a:t>Packaged monitor that sits next to any inference server, with SIEM-ready alerts and an audit log.</a:t>
+            </a:r>
+          </a:p>
+        </p:txBody>
+      </p:sp>
+      <p:cxnSp>
+        <p:nvCxnSpPr>
+          <p:cNvPr id="7" name="Connector 6"/>
+          <p:cNvCxnSpPr/>
+          <p:nvPr/>
+        </p:nvCxnSpPr>
+        <p:spPr>
+          <a:xfrm>
+            <a:off x="6323076" y="2057400"/>
+            <a:ext cx="5088636" cy="0"/>
+          </a:xfrm>
+          <a:prstGeom prst="line">
+            <a:avLst/>
+          </a:prstGeom>
+          <a:ln w="19050">
+            <a:solidFill>
+              <a:srgbClr val="1E1E1E"/>
+            </a:solidFill>
+          </a:ln>
+        </p:spPr>
+        <p:style>
+          <a:lnRef idx="2">
+            <a:schemeClr val="accent1"/>
+          </a:lnRef>
+          <a:fillRef idx="0">
+            <a:schemeClr val="accent1"/>
+          </a:fillRef>
+          <a:effectRef idx="1">
+            <a:schemeClr val="accent1"/>
+          </a:effectRef>
+          <a:fontRef idx="minor">
+            <a:schemeClr val="tx1"/>
+          </a:fontRef>
+        </p:style>
+      </p:cxnSp>
+      <p:sp>
+        <p:nvSpPr>
+          <p:cNvPr id="8" name="TextBox 7"/>
+          <p:cNvSpPr txBox="1"/>
+          <p:nvPr/>
+        </p:nvSpPr>
+        <p:spPr>
+          <a:xfrm>
+            <a:off x="6323076" y="2194560"/>
+            <a:ext cx="5088636" cy="411480"/>
+          </a:xfrm>
+          <a:prstGeom prst="rect">
+            <a:avLst/>
+          </a:prstGeom>
+          <a:noFill/>
+        </p:spPr>
+        <p:txBody>
+          <a:bodyPr wrap="square" anchor="t" lIns="0" rIns="0" tIns="0" bIns="0">
+            <a:spAutoFit/>
+          </a:bodyPr>
+          <a:lstStyle/>
+          <a:p>
+            <a:pPr algn="l">
+              <a:lnSpc>
+                <a:spcPct val="115000"/>
+              </a:lnSpc>
+            </a:pPr>
+            <a:r>
+              <a:rPr sz="1900" b="1" i="0">
+                <a:solidFill>
+                  <a:srgbClr val="1E1E1E"/>
+                </a:solidFill>
+                <a:latin typeface="Arial"/>
+              </a:rPr>
+              <a:t>2 · Calibration-drift guard</a:t>
+            </a:r>
+          </a:p>
+        </p:txBody>
+      </p:sp>
+      <p:sp>
+        <p:nvSpPr>
+          <p:cNvPr id="9" name="TextBox 8"/>
+          <p:cNvSpPr txBox="1"/>
+          <p:nvPr/>
+        </p:nvSpPr>
+        <p:spPr>
+          <a:xfrm>
+            <a:off x="6323076" y="2606040"/>
+            <a:ext cx="5088636" cy="1051560"/>
+          </a:xfrm>
+          <a:prstGeom prst="rect">
+            <a:avLst/>
+          </a:prstGeom>
+          <a:noFill/>
+        </p:spPr>
+        <p:txBody>
+          <a:bodyPr wrap="square" anchor="t" lIns="0" rIns="0" tIns="0" bIns="0">
+            <a:spAutoFit/>
+          </a:bodyPr>
+          <a:lstStyle/>
+          <a:p>
+            <a:pPr algn="l">
+              <a:lnSpc>
+                <a:spcPct val="130000"/>
+              </a:lnSpc>
+            </a:pPr>
+            <a:r>
+              <a:rPr sz="1400" b="0" i="0">
+                <a:solidFill>
+                  <a:srgbClr val="404040"/>
+                </a:solidFill>
+                <a:latin typeface="Arial"/>
+              </a:rPr>
+              <a:t>The paper’s guarantee needs calibration to transfer. We detect prompt or serving-stack drift and trigger recalibration automatically.</a:t>
+            </a:r>
+          </a:p>
+        </p:txBody>
+      </p:sp>
+      <p:cxnSp>
+        <p:nvCxnSpPr>
+          <p:cNvPr id="10" name="Connector 9"/>
+          <p:cNvCxnSpPr/>
+          <p:nvPr/>
+        </p:nvCxnSpPr>
+        <p:spPr>
+          <a:xfrm>
+            <a:off x="777240" y="3931920"/>
+            <a:ext cx="5088636" cy="0"/>
+          </a:xfrm>
+          <a:prstGeom prst="line">
+            <a:avLst/>
+          </a:prstGeom>
+          <a:ln w="19050">
+            <a:solidFill>
+              <a:srgbClr val="1E1E1E"/>
+            </a:solidFill>
+          </a:ln>
+        </p:spPr>
+        <p:style>
+          <a:lnRef idx="2">
+            <a:schemeClr val="accent1"/>
+          </a:lnRef>
+          <a:fillRef idx="0">
+            <a:schemeClr val="accent1"/>
+          </a:fillRef>
+          <a:effectRef idx="1">
+            <a:schemeClr val="accent1"/>
+          </a:effectRef>
+          <a:fontRef idx="minor">
+            <a:schemeClr val="tx1"/>
+          </a:fontRef>
+        </p:style>
+      </p:cxnSp>
+      <p:sp>
+        <p:nvSpPr>
+          <p:cNvPr id="11" name="TextBox 10"/>
+          <p:cNvSpPr txBox="1"/>
+          <p:nvPr/>
+        </p:nvSpPr>
+        <p:spPr>
+          <a:xfrm>
+            <a:off x="777240" y="4069080"/>
+            <a:ext cx="5088636" cy="411480"/>
+          </a:xfrm>
+          <a:prstGeom prst="rect">
+            <a:avLst/>
+          </a:prstGeom>
+          <a:noFill/>
+        </p:spPr>
+        <p:txBody>
+          <a:bodyPr wrap="square" anchor="t" lIns="0" rIns="0" tIns="0" bIns="0">
+            <a:spAutoFit/>
+          </a:bodyPr>
+          <a:lstStyle/>
+          <a:p>
+            <a:pPr algn="l">
+              <a:lnSpc>
+                <a:spcPct val="115000"/>
+              </a:lnSpc>
+            </a:pPr>
+            <a:r>
+              <a:rPr sz="1900" b="1" i="0">
+                <a:solidFill>
+                  <a:srgbClr val="1E1E1E"/>
+                </a:solidFill>
+                <a:latin typeface="Arial"/>
+              </a:rPr>
+              <a:t>3 · Respond, not just detect</a:t>
+            </a:r>
+          </a:p>
+        </p:txBody>
+      </p:sp>
+      <p:sp>
+        <p:nvSpPr>
+          <p:cNvPr id="12" name="TextBox 11"/>
+          <p:cNvSpPr txBox="1"/>
+          <p:nvPr/>
+        </p:nvSpPr>
+        <p:spPr>
+          <a:xfrm>
+            <a:off x="777240" y="4480560"/>
+            <a:ext cx="5088636" cy="1051560"/>
+          </a:xfrm>
+          <a:prstGeom prst="rect">
+            <a:avLst/>
+          </a:prstGeom>
+          <a:noFill/>
+        </p:spPr>
+        <p:txBody>
+          <a:bodyPr wrap="square" anchor="t" lIns="0" rIns="0" tIns="0" bIns="0">
+            <a:spAutoFit/>
+          </a:bodyPr>
+          <a:lstStyle/>
+          <a:p>
+            <a:pPr algn="l">
+              <a:lnSpc>
+                <a:spcPct val="130000"/>
+              </a:lnSpc>
+            </a:pPr>
+            <a:r>
+              <a:rPr sz="1400" b="0" i="0">
+                <a:solidFill>
+                  <a:srgbClr val="404040"/>
+                </a:solidFill>
+                <a:latin typeface="Arial"/>
+              </a:rPr>
+              <a:t>As evidence rises, automatically withhold logprobs and tighten rate limits — the attacker’s decoder depends on them.</a:t>
+            </a:r>
+          </a:p>
+        </p:txBody>
+      </p:sp>
+      <p:cxnSp>
+        <p:nvCxnSpPr>
+          <p:cNvPr id="13" name="Connector 12"/>
+          <p:cNvCxnSpPr/>
+          <p:nvPr/>
+        </p:nvCxnSpPr>
+        <p:spPr>
+          <a:xfrm>
+            <a:off x="6323076" y="3931920"/>
+            <a:ext cx="5088636" cy="0"/>
+          </a:xfrm>
+          <a:prstGeom prst="line">
+            <a:avLst/>
+          </a:prstGeom>
+          <a:ln w="19050">
+            <a:solidFill>
+              <a:srgbClr val="1E1E1E"/>
+            </a:solidFill>
+          </a:ln>
+        </p:spPr>
+        <p:style>
+          <a:lnRef idx="2">
+            <a:schemeClr val="accent1"/>
+          </a:lnRef>
+          <a:fillRef idx="0">
+            <a:schemeClr val="accent1"/>
+          </a:fillRef>
+          <a:effectRef idx="1">
+            <a:schemeClr val="accent1"/>
+          </a:effectRef>
+          <a:fontRef idx="minor">
+            <a:schemeClr val="tx1"/>
+          </a:fontRef>
+        </p:style>
+      </p:cxnSp>
+      <p:sp>
+        <p:nvSpPr>
+          <p:cNvPr id="14" name="TextBox 13"/>
+          <p:cNvSpPr txBox="1"/>
+          <p:nvPr/>
+        </p:nvSpPr>
+        <p:spPr>
+          <a:xfrm>
+            <a:off x="6323076" y="4069080"/>
+            <a:ext cx="5088636" cy="411480"/>
+          </a:xfrm>
+          <a:prstGeom prst="rect">
+            <a:avLst/>
+          </a:prstGeom>
+          <a:noFill/>
+        </p:spPr>
+        <p:txBody>
+          <a:bodyPr wrap="square" anchor="t" lIns="0" rIns="0" tIns="0" bIns="0">
+            <a:spAutoFit/>
+          </a:bodyPr>
+          <a:lstStyle/>
+          <a:p>
+            <a:pPr algn="l">
+              <a:lnSpc>
+                <a:spcPct val="115000"/>
+              </a:lnSpc>
+            </a:pPr>
+            <a:r>
+              <a:rPr sz="1900" b="1" i="0">
+                <a:solidFill>
+                  <a:srgbClr val="1E1E1E"/>
+                </a:solidFill>
+                <a:latin typeface="Arial"/>
+              </a:rPr>
+              <a:t>4 · One view of both sides</a:t>
+            </a:r>
+          </a:p>
+        </p:txBody>
+      </p:sp>
+      <p:sp>
+        <p:nvSpPr>
+          <p:cNvPr id="15" name="TextBox 14"/>
+          <p:cNvSpPr txBox="1"/>
+          <p:nvPr/>
+        </p:nvSpPr>
+        <p:spPr>
+          <a:xfrm>
+            <a:off x="6323076" y="4480560"/>
+            <a:ext cx="5088636" cy="1051560"/>
+          </a:xfrm>
+          <a:prstGeom prst="rect">
+            <a:avLst/>
+          </a:prstGeom>
+          <a:noFill/>
+        </p:spPr>
+        <p:txBody>
+          <a:bodyPr wrap="square" anchor="t" lIns="0" rIns="0" tIns="0" bIns="0">
+            <a:spAutoFit/>
+          </a:bodyPr>
+          <a:lstStyle/>
+          <a:p>
+            <a:pPr algn="l">
+              <a:lnSpc>
+                <a:spcPct val="130000"/>
+              </a:lnSpc>
+            </a:pPr>
+            <a:r>
+              <a:rPr sz="1400" b="0" i="0">
+                <a:solidFill>
+                  <a:srgbClr val="404040"/>
+                </a:solidFill>
+                <a:latin typeface="Arial"/>
+              </a:rPr>
+              <a:t>Server-side VILLE plus prompt-side garak scans and NeMo Guardrails in a single SOC dashboard, with Nemotron-written incident summaries.</a:t>
+            </a:r>
+          </a:p>
+        </p:txBody>
+      </p:sp>
+      <p:sp>
+        <p:nvSpPr>
+          <p:cNvPr id="16" name="TextBox 15"/>
+          <p:cNvSpPr txBox="1"/>
+          <p:nvPr/>
+        </p:nvSpPr>
+        <p:spPr>
+          <a:xfrm>
+            <a:off x="777240" y="5989320"/>
+            <a:ext cx="8961120" cy="457200"/>
+          </a:xfrm>
+          <a:prstGeom prst="rect">
+            <a:avLst/>
+          </a:prstGeom>
+          <a:noFill/>
+        </p:spPr>
+        <p:txBody>
+          <a:bodyPr wrap="square" anchor="t" lIns="0" rIns="0" tIns="0" bIns="0">
+            <a:spAutoFit/>
+          </a:bodyPr>
+          <a:lstStyle/>
+          <a:p>
+            <a:pPr algn="l">
+              <a:lnSpc>
+                <a:spcPct val="115000"/>
+              </a:lnSpc>
+            </a:pPr>
+            <a:r>
+              <a:rPr sz="1100" b="0" i="0">
+                <a:solidFill>
+                  <a:srgbClr val="6B6B6B"/>
+                </a:solidFill>
+                <a:latin typeface="Arial"/>
+              </a:rPr>
+              <a:t>Items 1–4 are our proposals; the detector and its guarantee are the paper’s.</a:t>
+            </a:r>
+          </a:p>
+        </p:txBody>
+      </p:sp>
+      <p:sp>
+        <p:nvSpPr>
+          <p:cNvPr id="17" name="TextBox 16"/>
+          <p:cNvSpPr txBox="1"/>
+          <p:nvPr/>
+        </p:nvSpPr>
+        <p:spPr>
+          <a:xfrm>
+            <a:off x="9966960" y="6263640"/>
+            <a:ext cx="1444752" cy="274320"/>
+          </a:xfrm>
+          <a:prstGeom prst="rect">
+            <a:avLst/>
+          </a:prstGeom>
+          <a:noFill/>
+        </p:spPr>
+        <p:txBody>
+          <a:bodyPr wrap="square" anchor="t" lIns="0" rIns="0" tIns="0" bIns="0">
+            <a:spAutoFit/>
+          </a:bodyPr>
+          <a:lstStyle/>
+          <a:p>
+            <a:pPr algn="r">
+              <a:lnSpc>
+                <a:spcPct val="115000"/>
+              </a:lnSpc>
+            </a:pPr>
+            <a:r>
+              <a:rPr sz="1100" b="0" i="0">
+                <a:solidFill>
+                  <a:srgbClr val="6B6B6B"/>
+                </a:solidFill>
+                <a:latin typeface="Arial"/>
+              </a:rPr>
+              <a:t>Team REIGN  ·  8</a:t>
+            </a:r>
+          </a:p>
+        </p:txBody>
+      </p:sp>
+    </p:spTree>
+  </p:cSld>
+  <p:clrMapOvr>
+    <a:masterClrMapping/>
+  </p:clrMapOvr>
+</p:sld>
+</file>
+
+<file path=ppt/slides/slide9.xml><?xml version="1.0" encoding="utf-8"?>
+<p:sld xmlns:a="http://schemas.openxmlformats.org/drawingml/2006/main" xmlns:p="http://schemas.openxmlformats.org/presentationml/2006/main" xmlns:r="http://schemas.openxmlformats.org/officeDocument/2006/relationships">
+  <p:cSld>
+    <p:bg>
+      <p:bgPr>
+        <a:solidFill>
+          <a:srgbClr val="FAF8F3"/>
+        </a:solidFill>
+        <a:effectLst/>
+      </p:bgPr>
+    </p:bg>
+    <p:spTree>
+      <p:nvGrpSpPr>
+        <p:cNvPr id="1" name=""/>
+        <p:cNvGrpSpPr/>
+        <p:nvPr/>
+      </p:nvGrpSpPr>
+      <p:grpSpPr/>
+      <p:sp>
+        <p:nvSpPr>
+          <p:cNvPr id="2" name="TextBox 1"/>
+          <p:cNvSpPr txBox="1"/>
+          <p:nvPr/>
+        </p:nvSpPr>
+        <p:spPr>
+          <a:xfrm>
+            <a:off x="777240" y="548640"/>
+            <a:ext cx="10634472" cy="365760"/>
+          </a:xfrm>
+          <a:prstGeom prst="rect">
+            <a:avLst/>
+          </a:prstGeom>
+          <a:noFill/>
+        </p:spPr>
+        <p:txBody>
+          <a:bodyPr wrap="square" anchor="t" lIns="0" rIns="0" tIns="0" bIns="0">
+            <a:spAutoFit/>
+          </a:bodyPr>
+          <a:lstStyle/>
+          <a:p>
+            <a:pPr algn="l">
+              <a:lnSpc>
+                <a:spcPct val="115000"/>
+              </a:lnSpc>
+            </a:pPr>
+            <a:r>
+              <a:rPr sz="1300" b="1" i="0">
+                <a:solidFill>
+                  <a:srgbClr val="7A1F1F"/>
+                </a:solidFill>
+                <a:latin typeface="Arial"/>
+              </a:rPr>
+              <a:t>08  ·  PROPOSED TECHNOLOGY STACK</a:t>
             </a:r>
           </a:p>
         </p:txBody>
@@ -6917,601 +8147,6 @@
       <p:sp>
         <p:nvSpPr>
           <p:cNvPr id="6" name="TextBox 5"/>
-          <p:cNvSpPr txBox="1"/>
-          <p:nvPr/>
-        </p:nvSpPr>
-        <p:spPr>
-          <a:xfrm>
-            <a:off x="9966960" y="6263640"/>
-            <a:ext cx="1444752" cy="274320"/>
-          </a:xfrm>
-          <a:prstGeom prst="rect">
-            <a:avLst/>
-          </a:prstGeom>
-          <a:noFill/>
-        </p:spPr>
-        <p:txBody>
-          <a:bodyPr wrap="square" anchor="t" lIns="0" rIns="0" tIns="0" bIns="0">
-            <a:spAutoFit/>
-          </a:bodyPr>
-          <a:lstStyle/>
-          <a:p>
-            <a:pPr algn="r">
-              <a:lnSpc>
-                <a:spcPct val="115000"/>
-              </a:lnSpc>
-            </a:pPr>
-            <a:r>
-              <a:rPr sz="1100" b="0" i="0">
-                <a:solidFill>
-                  <a:srgbClr val="6B6B6B"/>
-                </a:solidFill>
-                <a:latin typeface="Arial"/>
-              </a:rPr>
-              <a:t>Team REIGN  ·  8</a:t>
-            </a:r>
-          </a:p>
-        </p:txBody>
-      </p:sp>
-    </p:spTree>
-  </p:cSld>
-  <p:clrMapOvr>
-    <a:masterClrMapping/>
-  </p:clrMapOvr>
-</p:sld>
-</file>
-
-<file path=ppt/slides/slide9.xml><?xml version="1.0" encoding="utf-8"?>
-<p:sld xmlns:a="http://schemas.openxmlformats.org/drawingml/2006/main" xmlns:p="http://schemas.openxmlformats.org/presentationml/2006/main" xmlns:r="http://schemas.openxmlformats.org/officeDocument/2006/relationships">
-  <p:cSld>
-    <p:bg>
-      <p:bgPr>
-        <a:solidFill>
-          <a:srgbClr val="FAF8F3"/>
-        </a:solidFill>
-        <a:effectLst/>
-      </p:bgPr>
-    </p:bg>
-    <p:spTree>
-      <p:nvGrpSpPr>
-        <p:cNvPr id="1" name=""/>
-        <p:cNvGrpSpPr/>
-        <p:nvPr/>
-      </p:nvGrpSpPr>
-      <p:grpSpPr/>
-      <p:sp>
-        <p:nvSpPr>
-          <p:cNvPr id="2" name="TextBox 1"/>
-          <p:cNvSpPr txBox="1"/>
-          <p:nvPr/>
-        </p:nvSpPr>
-        <p:spPr>
-          <a:xfrm>
-            <a:off x="777240" y="548640"/>
-            <a:ext cx="10634472" cy="365760"/>
-          </a:xfrm>
-          <a:prstGeom prst="rect">
-            <a:avLst/>
-          </a:prstGeom>
-          <a:noFill/>
-        </p:spPr>
-        <p:txBody>
-          <a:bodyPr wrap="square" anchor="t" lIns="0" rIns="0" tIns="0" bIns="0">
-            <a:spAutoFit/>
-          </a:bodyPr>
-          <a:lstStyle/>
-          <a:p>
-            <a:pPr algn="l">
-              <a:lnSpc>
-                <a:spcPct val="115000"/>
-              </a:lnSpc>
-            </a:pPr>
-            <a:r>
-              <a:rPr sz="1300" b="1" i="0">
-                <a:solidFill>
-                  <a:srgbClr val="7A1F1F"/>
-                </a:solidFill>
-                <a:latin typeface="Arial"/>
-              </a:rPr>
-              <a:t>08  ·  FEASIBILITY &amp; KNOWN LIMITS</a:t>
-            </a:r>
-          </a:p>
-        </p:txBody>
-      </p:sp>
-      <p:sp>
-        <p:nvSpPr>
-          <p:cNvPr id="3" name="TextBox 2"/>
-          <p:cNvSpPr txBox="1"/>
-          <p:nvPr/>
-        </p:nvSpPr>
-        <p:spPr>
-          <a:xfrm>
-            <a:off x="777240" y="914400"/>
-            <a:ext cx="10634472" cy="1280160"/>
-          </a:xfrm>
-          <a:prstGeom prst="rect">
-            <a:avLst/>
-          </a:prstGeom>
-          <a:noFill/>
-        </p:spPr>
-        <p:txBody>
-          <a:bodyPr wrap="square" anchor="t" lIns="0" rIns="0" tIns="0" bIns="0">
-            <a:spAutoFit/>
-          </a:bodyPr>
-          <a:lstStyle/>
-          <a:p>
-            <a:pPr algn="l">
-              <a:lnSpc>
-                <a:spcPct val="110000"/>
-              </a:lnSpc>
-            </a:pPr>
-            <a:r>
-              <a:rPr sz="3400" b="0" i="0">
-                <a:solidFill>
-                  <a:srgbClr val="1E1E1E"/>
-                </a:solidFill>
-                <a:latin typeface="Georgia"/>
-              </a:rPr>
-              <a:t>What the paper says it cannot yet do</a:t>
-            </a:r>
-          </a:p>
-        </p:txBody>
-      </p:sp>
-      <p:cxnSp>
-        <p:nvCxnSpPr>
-          <p:cNvPr id="4" name="Connector 3"/>
-          <p:cNvCxnSpPr/>
-          <p:nvPr/>
-        </p:nvCxnSpPr>
-        <p:spPr>
-          <a:xfrm>
-            <a:off x="777240" y="1920240"/>
-            <a:ext cx="5088636" cy="0"/>
-          </a:xfrm>
-          <a:prstGeom prst="line">
-            <a:avLst/>
-          </a:prstGeom>
-          <a:ln w="19050">
-            <a:solidFill>
-              <a:srgbClr val="1E1E1E"/>
-            </a:solidFill>
-          </a:ln>
-        </p:spPr>
-        <p:style>
-          <a:lnRef idx="2">
-            <a:schemeClr val="accent1"/>
-          </a:lnRef>
-          <a:fillRef idx="0">
-            <a:schemeClr val="accent1"/>
-          </a:fillRef>
-          <a:effectRef idx="1">
-            <a:schemeClr val="accent1"/>
-          </a:effectRef>
-          <a:fontRef idx="minor">
-            <a:schemeClr val="tx1"/>
-          </a:fontRef>
-        </p:style>
-      </p:cxnSp>
-      <p:sp>
-        <p:nvSpPr>
-          <p:cNvPr id="5" name="TextBox 4"/>
-          <p:cNvSpPr txBox="1"/>
-          <p:nvPr/>
-        </p:nvSpPr>
-        <p:spPr>
-          <a:xfrm>
-            <a:off x="777240" y="2057400"/>
-            <a:ext cx="5088636" cy="411480"/>
-          </a:xfrm>
-          <a:prstGeom prst="rect">
-            <a:avLst/>
-          </a:prstGeom>
-          <a:noFill/>
-        </p:spPr>
-        <p:txBody>
-          <a:bodyPr wrap="square" anchor="t" lIns="0" rIns="0" tIns="0" bIns="0">
-            <a:spAutoFit/>
-          </a:bodyPr>
-          <a:lstStyle/>
-          <a:p>
-            <a:pPr algn="l">
-              <a:lnSpc>
-                <a:spcPct val="115000"/>
-              </a:lnSpc>
-            </a:pPr>
-            <a:r>
-              <a:rPr sz="1900" b="1" i="0">
-                <a:solidFill>
-                  <a:srgbClr val="1E1E1E"/>
-                </a:solidFill>
-                <a:latin typeface="Arial"/>
-              </a:rPr>
-              <a:t>Slow, seed-aware attackers</a:t>
-            </a:r>
-          </a:p>
-        </p:txBody>
-      </p:sp>
-      <p:sp>
-        <p:nvSpPr>
-          <p:cNvPr id="6" name="TextBox 5"/>
-          <p:cNvSpPr txBox="1"/>
-          <p:nvPr/>
-        </p:nvSpPr>
-        <p:spPr>
-          <a:xfrm>
-            <a:off x="777240" y="2468880"/>
-            <a:ext cx="5088636" cy="1051560"/>
-          </a:xfrm>
-          <a:prstGeom prst="rect">
-            <a:avLst/>
-          </a:prstGeom>
-          <a:noFill/>
-        </p:spPr>
-        <p:txBody>
-          <a:bodyPr wrap="square" anchor="t" lIns="0" rIns="0" tIns="0" bIns="0">
-            <a:spAutoFit/>
-          </a:bodyPr>
-          <a:lstStyle/>
-          <a:p>
-            <a:pPr algn="l">
-              <a:lnSpc>
-                <a:spcPct val="130000"/>
-              </a:lnSpc>
-            </a:pPr>
-            <a:r>
-              <a:rPr sz="1500" b="0" i="0">
-                <a:solidFill>
-                  <a:srgbClr val="404040"/>
-                </a:solidFill>
-                <a:latin typeface="Arial"/>
-              </a:rPr>
-              <a:t>Attacks sending a few hundredths of a bit per token can go undetected within 250 responses.</a:t>
-            </a:r>
-          </a:p>
-        </p:txBody>
-      </p:sp>
-      <p:cxnSp>
-        <p:nvCxnSpPr>
-          <p:cNvPr id="7" name="Connector 6"/>
-          <p:cNvCxnSpPr/>
-          <p:nvPr/>
-        </p:nvCxnSpPr>
-        <p:spPr>
-          <a:xfrm>
-            <a:off x="6323076" y="1920240"/>
-            <a:ext cx="5088636" cy="0"/>
-          </a:xfrm>
-          <a:prstGeom prst="line">
-            <a:avLst/>
-          </a:prstGeom>
-          <a:ln w="19050">
-            <a:solidFill>
-              <a:srgbClr val="1E1E1E"/>
-            </a:solidFill>
-          </a:ln>
-        </p:spPr>
-        <p:style>
-          <a:lnRef idx="2">
-            <a:schemeClr val="accent1"/>
-          </a:lnRef>
-          <a:fillRef idx="0">
-            <a:schemeClr val="accent1"/>
-          </a:fillRef>
-          <a:effectRef idx="1">
-            <a:schemeClr val="accent1"/>
-          </a:effectRef>
-          <a:fontRef idx="minor">
-            <a:schemeClr val="tx1"/>
-          </a:fontRef>
-        </p:style>
-      </p:cxnSp>
-      <p:sp>
-        <p:nvSpPr>
-          <p:cNvPr id="8" name="TextBox 7"/>
-          <p:cNvSpPr txBox="1"/>
-          <p:nvPr/>
-        </p:nvSpPr>
-        <p:spPr>
-          <a:xfrm>
-            <a:off x="6323076" y="2057400"/>
-            <a:ext cx="5088636" cy="411480"/>
-          </a:xfrm>
-          <a:prstGeom prst="rect">
-            <a:avLst/>
-          </a:prstGeom>
-          <a:noFill/>
-        </p:spPr>
-        <p:txBody>
-          <a:bodyPr wrap="square" anchor="t" lIns="0" rIns="0" tIns="0" bIns="0">
-            <a:spAutoFit/>
-          </a:bodyPr>
-          <a:lstStyle/>
-          <a:p>
-            <a:pPr algn="l">
-              <a:lnSpc>
-                <a:spcPct val="115000"/>
-              </a:lnSpc>
-            </a:pPr>
-            <a:r>
-              <a:rPr sz="1900" b="1" i="0">
-                <a:solidFill>
-                  <a:srgbClr val="1E1E1E"/>
-                </a:solidFill>
-                <a:latin typeface="Arial"/>
-              </a:rPr>
-              <a:t>Noisier model stacks</a:t>
-            </a:r>
-          </a:p>
-        </p:txBody>
-      </p:sp>
-      <p:sp>
-        <p:nvSpPr>
-          <p:cNvPr id="9" name="TextBox 8"/>
-          <p:cNvSpPr txBox="1"/>
-          <p:nvPr/>
-        </p:nvSpPr>
-        <p:spPr>
-          <a:xfrm>
-            <a:off x="6323076" y="2468880"/>
-            <a:ext cx="5088636" cy="1051560"/>
-          </a:xfrm>
-          <a:prstGeom prst="rect">
-            <a:avLst/>
-          </a:prstGeom>
-          <a:noFill/>
-        </p:spPr>
-        <p:txBody>
-          <a:bodyPr wrap="square" anchor="t" lIns="0" rIns="0" tIns="0" bIns="0">
-            <a:spAutoFit/>
-          </a:bodyPr>
-          <a:lstStyle/>
-          <a:p>
-            <a:pPr algn="l">
-              <a:lnSpc>
-                <a:spcPct val="130000"/>
-              </a:lnSpc>
-            </a:pPr>
-            <a:r>
-              <a:rPr sz="1500" b="0" i="0">
-                <a:solidFill>
-                  <a:srgbClr val="404040"/>
-                </a:solidFill>
-                <a:latin typeface="Arial"/>
-              </a:rPr>
-              <a:t>Both mixture-of-experts models showed 3–4× more benign mismatches, giving attackers more cover.</a:t>
-            </a:r>
-          </a:p>
-        </p:txBody>
-      </p:sp>
-      <p:cxnSp>
-        <p:nvCxnSpPr>
-          <p:cNvPr id="10" name="Connector 9"/>
-          <p:cNvCxnSpPr/>
-          <p:nvPr/>
-        </p:nvCxnSpPr>
-        <p:spPr>
-          <a:xfrm>
-            <a:off x="777240" y="3794760"/>
-            <a:ext cx="5088636" cy="0"/>
-          </a:xfrm>
-          <a:prstGeom prst="line">
-            <a:avLst/>
-          </a:prstGeom>
-          <a:ln w="19050">
-            <a:solidFill>
-              <a:srgbClr val="1E1E1E"/>
-            </a:solidFill>
-          </a:ln>
-        </p:spPr>
-        <p:style>
-          <a:lnRef idx="2">
-            <a:schemeClr val="accent1"/>
-          </a:lnRef>
-          <a:fillRef idx="0">
-            <a:schemeClr val="accent1"/>
-          </a:fillRef>
-          <a:effectRef idx="1">
-            <a:schemeClr val="accent1"/>
-          </a:effectRef>
-          <a:fontRef idx="minor">
-            <a:schemeClr val="tx1"/>
-          </a:fontRef>
-        </p:style>
-      </p:cxnSp>
-      <p:sp>
-        <p:nvSpPr>
-          <p:cNvPr id="11" name="TextBox 10"/>
-          <p:cNvSpPr txBox="1"/>
-          <p:nvPr/>
-        </p:nvSpPr>
-        <p:spPr>
-          <a:xfrm>
-            <a:off x="777240" y="3931920"/>
-            <a:ext cx="5088636" cy="411480"/>
-          </a:xfrm>
-          <a:prstGeom prst="rect">
-            <a:avLst/>
-          </a:prstGeom>
-          <a:noFill/>
-        </p:spPr>
-        <p:txBody>
-          <a:bodyPr wrap="square" anchor="t" lIns="0" rIns="0" tIns="0" bIns="0">
-            <a:spAutoFit/>
-          </a:bodyPr>
-          <a:lstStyle/>
-          <a:p>
-            <a:pPr algn="l">
-              <a:lnSpc>
-                <a:spcPct val="115000"/>
-              </a:lnSpc>
-            </a:pPr>
-            <a:r>
-              <a:rPr sz="1900" b="1" i="0">
-                <a:solidFill>
-                  <a:srgbClr val="1E1E1E"/>
-                </a:solidFill>
-                <a:latin typeface="Arial"/>
-              </a:rPr>
-              <a:t>Calibration must transfer</a:t>
-            </a:r>
-          </a:p>
-        </p:txBody>
-      </p:sp>
-      <p:sp>
-        <p:nvSpPr>
-          <p:cNvPr id="12" name="TextBox 11"/>
-          <p:cNvSpPr txBox="1"/>
-          <p:nvPr/>
-        </p:nvSpPr>
-        <p:spPr>
-          <a:xfrm>
-            <a:off x="777240" y="4343400"/>
-            <a:ext cx="5088636" cy="1051560"/>
-          </a:xfrm>
-          <a:prstGeom prst="rect">
-            <a:avLst/>
-          </a:prstGeom>
-          <a:noFill/>
-        </p:spPr>
-        <p:txBody>
-          <a:bodyPr wrap="square" anchor="t" lIns="0" rIns="0" tIns="0" bIns="0">
-            <a:spAutoFit/>
-          </a:bodyPr>
-          <a:lstStyle/>
-          <a:p>
-            <a:pPr algn="l">
-              <a:lnSpc>
-                <a:spcPct val="130000"/>
-              </a:lnSpc>
-            </a:pPr>
-            <a:r>
-              <a:rPr sz="1500" b="0" i="0">
-                <a:solidFill>
-                  <a:srgbClr val="404040"/>
-                </a:solidFill>
-                <a:latin typeface="Arial"/>
-              </a:rPr>
-              <a:t>The guarantee assumes the same prompts, model, hardware and serving stack as calibration.</a:t>
-            </a:r>
-          </a:p>
-        </p:txBody>
-      </p:sp>
-      <p:cxnSp>
-        <p:nvCxnSpPr>
-          <p:cNvPr id="13" name="Connector 12"/>
-          <p:cNvCxnSpPr/>
-          <p:nvPr/>
-        </p:nvCxnSpPr>
-        <p:spPr>
-          <a:xfrm>
-            <a:off x="6323076" y="3794760"/>
-            <a:ext cx="5088636" cy="0"/>
-          </a:xfrm>
-          <a:prstGeom prst="line">
-            <a:avLst/>
-          </a:prstGeom>
-          <a:ln w="19050">
-            <a:solidFill>
-              <a:srgbClr val="1E1E1E"/>
-            </a:solidFill>
-          </a:ln>
-        </p:spPr>
-        <p:style>
-          <a:lnRef idx="2">
-            <a:schemeClr val="accent1"/>
-          </a:lnRef>
-          <a:fillRef idx="0">
-            <a:schemeClr val="accent1"/>
-          </a:fillRef>
-          <a:effectRef idx="1">
-            <a:schemeClr val="accent1"/>
-          </a:effectRef>
-          <a:fontRef idx="minor">
-            <a:schemeClr val="tx1"/>
-          </a:fontRef>
-        </p:style>
-      </p:cxnSp>
-      <p:sp>
-        <p:nvSpPr>
-          <p:cNvPr id="14" name="TextBox 13"/>
-          <p:cNvSpPr txBox="1"/>
-          <p:nvPr/>
-        </p:nvSpPr>
-        <p:spPr>
-          <a:xfrm>
-            <a:off x="6323076" y="3931920"/>
-            <a:ext cx="5088636" cy="411480"/>
-          </a:xfrm>
-          <a:prstGeom prst="rect">
-            <a:avLst/>
-          </a:prstGeom>
-          <a:noFill/>
-        </p:spPr>
-        <p:txBody>
-          <a:bodyPr wrap="square" anchor="t" lIns="0" rIns="0" tIns="0" bIns="0">
-            <a:spAutoFit/>
-          </a:bodyPr>
-          <a:lstStyle/>
-          <a:p>
-            <a:pPr algn="l">
-              <a:lnSpc>
-                <a:spcPct val="115000"/>
-              </a:lnSpc>
-            </a:pPr>
-            <a:r>
-              <a:rPr sz="1900" b="1" i="0">
-                <a:solidFill>
-                  <a:srgbClr val="1E1E1E"/>
-                </a:solidFill>
-                <a:latin typeface="Arial"/>
-              </a:rPr>
-              <a:t>Small secrets still escape</a:t>
-            </a:r>
-          </a:p>
-        </p:txBody>
-      </p:sp>
-      <p:sp>
-        <p:nvSpPr>
-          <p:cNvPr id="15" name="TextBox 14"/>
-          <p:cNvSpPr txBox="1"/>
-          <p:nvPr/>
-        </p:nvSpPr>
-        <p:spPr>
-          <a:xfrm>
-            <a:off x="6323076" y="4343400"/>
-            <a:ext cx="5088636" cy="1051560"/>
-          </a:xfrm>
-          <a:prstGeom prst="rect">
-            <a:avLst/>
-          </a:prstGeom>
-          <a:noFill/>
-        </p:spPr>
-        <p:txBody>
-          <a:bodyPr wrap="square" anchor="t" lIns="0" rIns="0" tIns="0" bIns="0">
-            <a:spAutoFit/>
-          </a:bodyPr>
-          <a:lstStyle/>
-          <a:p>
-            <a:pPr algn="l">
-              <a:lnSpc>
-                <a:spcPct val="130000"/>
-              </a:lnSpc>
-            </a:pPr>
-            <a:r>
-              <a:rPr sz="1500" b="0" i="0">
-                <a:solidFill>
-                  <a:srgbClr val="404040"/>
-                </a:solidFill>
-                <a:latin typeface="Arial"/>
-              </a:rPr>
-              <a:t>Low rates slow bulk weight theft, but do not stop leaking short secrets such as keys.</a:t>
-            </a:r>
-          </a:p>
-        </p:txBody>
-      </p:sp>
-      <p:sp>
-        <p:nvSpPr>
-          <p:cNvPr id="16" name="TextBox 15"/>
           <p:cNvSpPr txBox="1"/>
           <p:nvPr/>
         </p:nvSpPr>

</xml_diff>